<commit_message>
Hints nos cabecalhos do cronograma + coluna %Daily + PPT com logo transparente (v1.0.46.16)
- Tooltip (nome + descricao) em cada coluna do TaskGridControl, i18n pt-BR/en-US
- Coluna %Daily (% esperado ate hoje) com toggle e destaque de desvio
- Scripts gera_ppt: novas funcionalidades e logo Nexus XData transparente no encerramento
</commit_message>
<xml_diff>
--- a/NXProject_Gestao_Inteligente_DevOps.pptx
+++ b/NXProject_Gestao_Inteligente_DevOps.pptx
@@ -5396,7 +5396,8 @@
               </a:rPr>
               <a:t>• Cascata automática por predecessoras
 • Predecessora virtual por recurso
-• Calendário com feriados e horas úteis</a:t>
+• Calendário com feriados e horas úteis
+• Coluna %Daily: ritmo esperado até hoje</a:t>
             </a:r>
           </a:p>
         </p:txBody>
@@ -5715,8 +5716,9 @@
                 </a:solidFill>
               </a:rPr>
               <a:t>• Alocação por pessoa e sprint
-• Alerta de sobrecarga (&gt;100%)
-• Filtro de cronograma por pessoa</a:t>
+• Descoberta e importação de pessoas do DevOps
+• Custo por recurso (importa e calcula)
+• Alerta de sobrecarga (&gt;100%)</a:t>
             </a:r>
           </a:p>
         </p:txBody>
@@ -5876,6 +5878,7 @@
               </a:rPr>
               <a:t>• Datas, horas, estado, sprint, tags e predecessoras
 • Cria work items novos no DevOps
+• Revisão Tech Lead: cria/edita tasks online
 • Relatório detalhado de sincronização</a:t>
             </a:r>
           </a:p>
@@ -6035,8 +6038,8 @@
                 </a:solidFill>
               </a:rPr>
               <a:t>• Atividades em atraso (Fim &lt; hoje e % &lt; 100)
-• Itens sem responsável
-• Dependências circulares e bloqueios</a:t>
+• Desvio %Daily vs % informado
+• Itens sem responsável e dependências circulares</a:t>
             </a:r>
           </a:p>
         </p:txBody>
@@ -9551,40 +9554,30 @@
           </a:p>
         </p:txBody>
       </p:sp>
-      <p:sp>
-        <p:nvSpPr>
-          <p:cNvPr id="8" name="TextBox 7"/>
-          <p:cNvSpPr txBox="1"/>
-          <p:nvPr/>
-        </p:nvSpPr>
-        <p:spPr>
-          <a:xfrm>
-            <a:off x="914400" y="6126480"/>
-            <a:ext cx="10332720" cy="365760"/>
-          </a:xfrm>
-          <a:prstGeom prst="rect">
-            <a:avLst/>
-          </a:prstGeom>
-          <a:noFill/>
-        </p:spPr>
-        <p:txBody>
-          <a:bodyPr wrap="square">
-            <a:spAutoFit/>
-          </a:bodyPr>
-          <a:lstStyle/>
-          <a:p>
-            <a:pPr algn="ctr"/>
-            <a:r>
-              <a:rPr sz="1100" b="0" i="0">
-                <a:solidFill>
-                  <a:srgbClr val="7A9AC8"/>
-                </a:solidFill>
-              </a:rPr>
-              <a:t>Nexus XData Tecnologia Ltda</a:t>
-            </a:r>
-          </a:p>
-        </p:txBody>
-      </p:sp>
+      <p:pic>
+        <p:nvPicPr>
+          <p:cNvPr id="8" name="Picture 7" descr="logo-nexus-xdata-transparent.png"/>
+          <p:cNvPicPr>
+            <a:picLocks noChangeAspect="1"/>
+          </p:cNvPicPr>
+          <p:nvPr/>
+        </p:nvPicPr>
+        <p:blipFill>
+          <a:blip r:embed="rId2"/>
+          <a:stretch>
+            <a:fillRect/>
+          </a:stretch>
+        </p:blipFill>
+        <p:spPr>
+          <a:xfrm>
+            <a:off x="5522976" y="5074920"/>
+            <a:ext cx="1143000" cy="1143000"/>
+          </a:xfrm>
+          <a:prstGeom prst="rect">
+            <a:avLst/>
+          </a:prstGeom>
+        </p:spPr>
+      </p:pic>
     </p:spTree>
   </p:cSld>
   <p:clrMapOvr>

</xml_diff>